<commit_message>
refactor(sdk): simplify DriverServiceImpl and SdkServiceImpl initialization logic
</commit_message>
<xml_diff>
--- a/dc3/doc/framework/iot-dc3-architecture.pptx
+++ b/dc3/doc/framework/iot-dc3-architecture.pptx
@@ -21916,6 +21916,7 @@
               </a:avLst>
             </a:prstGeom>
             <a:noFill/>
+            <a:ln w="6350"/>
           </p:spPr>
           <p:style>
             <a:lnRef idx="2">
@@ -21982,6 +21983,7 @@
               </a:avLst>
             </a:prstGeom>
             <a:noFill/>
+            <a:ln w="6350"/>
           </p:spPr>
           <p:style>
             <a:lnRef idx="2">
@@ -22032,6 +22034,7 @@
               </a:avLst>
             </a:prstGeom>
             <a:noFill/>
+            <a:ln w="6350"/>
           </p:spPr>
           <p:style>
             <a:lnRef idx="2">
@@ -22087,6 +22090,7 @@
               </a:avLst>
             </a:prstGeom>
             <a:noFill/>
+            <a:ln w="6350"/>
           </p:spPr>
           <p:style>
             <a:lnRef idx="2">
@@ -22158,6 +22162,7 @@
               </a:avLst>
             </a:prstGeom>
             <a:noFill/>
+            <a:ln w="6350"/>
           </p:spPr>
           <p:style>
             <a:lnRef idx="2">
@@ -22213,6 +22218,7 @@
               </a:avLst>
             </a:prstGeom>
             <a:noFill/>
+            <a:ln w="6350"/>
           </p:spPr>
           <p:style>
             <a:lnRef idx="2">
@@ -22268,6 +22274,7 @@
               </a:avLst>
             </a:prstGeom>
             <a:noFill/>
+            <a:ln w="6350"/>
           </p:spPr>
           <p:style>
             <a:lnRef idx="2">
@@ -22323,7 +22330,7 @@
               <a:gd name="adj" fmla="val 7576"/>
             </a:avLst>
           </a:prstGeom>
-          <a:ln>
+          <a:ln w="6350">
             <a:solidFill>
               <a:schemeClr val="accent1">
                 <a:lumMod val="75000"/>
@@ -22443,6 +22450,7 @@
               </a:avLst>
             </a:prstGeom>
             <a:noFill/>
+            <a:ln w="6350"/>
           </p:spPr>
           <p:style>
             <a:lnRef idx="2">
@@ -22497,6 +22505,7 @@
                 <a:gd name="adj" fmla="val 7576"/>
               </a:avLst>
             </a:prstGeom>
+            <a:ln w="6350"/>
           </p:spPr>
           <p:style>
             <a:lnRef idx="2">
@@ -22549,6 +22558,7 @@
                 <a:gd name="adj" fmla="val 7576"/>
               </a:avLst>
             </a:prstGeom>
+            <a:ln w="6350"/>
           </p:spPr>
           <p:style>
             <a:lnRef idx="2">
@@ -22601,6 +22611,7 @@
                 <a:gd name="adj" fmla="val 7576"/>
               </a:avLst>
             </a:prstGeom>
+            <a:ln w="6350"/>
           </p:spPr>
           <p:style>
             <a:lnRef idx="2">
@@ -22653,6 +22664,7 @@
                 <a:gd name="adj" fmla="val 7576"/>
               </a:avLst>
             </a:prstGeom>
+            <a:ln w="6350"/>
           </p:spPr>
           <p:style>
             <a:lnRef idx="2">
@@ -22704,6 +22716,11 @@
               <a:avLst/>
             </a:prstGeom>
             <a:noFill/>
+            <a:ln w="6350">
+              <a:solidFill>
+                <a:schemeClr val="tx1"/>
+              </a:solidFill>
+            </a:ln>
           </p:spPr>
           <p:txBody>
             <a:bodyPr wrap="none" rtlCol="0">
@@ -22742,6 +22759,11 @@
               <a:avLst/>
             </a:prstGeom>
             <a:noFill/>
+            <a:ln w="6350">
+              <a:solidFill>
+                <a:schemeClr val="tx1"/>
+              </a:solidFill>
+            </a:ln>
           </p:spPr>
           <p:txBody>
             <a:bodyPr wrap="none" rtlCol="0">
@@ -22788,6 +22810,11 @@
               <a:avLst/>
             </a:prstGeom>
             <a:noFill/>
+            <a:ln w="6350">
+              <a:solidFill>
+                <a:schemeClr val="tx1"/>
+              </a:solidFill>
+            </a:ln>
           </p:spPr>
           <p:txBody>
             <a:bodyPr wrap="none" rtlCol="0">
@@ -22826,6 +22853,11 @@
               <a:avLst/>
             </a:prstGeom>
             <a:noFill/>
+            <a:ln w="6350">
+              <a:solidFill>
+                <a:schemeClr val="tx1"/>
+              </a:solidFill>
+            </a:ln>
           </p:spPr>
           <p:txBody>
             <a:bodyPr wrap="none" rtlCol="0">
@@ -22895,7 +22927,7 @@
               <a:avLst/>
             </a:prstGeom>
             <a:noFill/>
-            <a:ln>
+            <a:ln w="6350">
               <a:solidFill>
                 <a:schemeClr val="accent2"/>
               </a:solidFill>
@@ -22945,7 +22977,7 @@
               <a:avLst/>
             </a:prstGeom>
             <a:noFill/>
-            <a:ln>
+            <a:ln w="6350">
               <a:solidFill>
                 <a:schemeClr val="accent1"/>
               </a:solidFill>
@@ -23012,6 +23044,7 @@
               </a:avLst>
             </a:prstGeom>
             <a:noFill/>
+            <a:ln w="6350"/>
           </p:spPr>
           <p:style>
             <a:lnRef idx="2">
@@ -23067,6 +23100,7 @@
               </a:avLst>
             </a:prstGeom>
             <a:noFill/>
+            <a:ln w="6350"/>
           </p:spPr>
           <p:style>
             <a:lnRef idx="2">
@@ -23122,6 +23156,7 @@
               </a:avLst>
             </a:prstGeom>
             <a:noFill/>
+            <a:ln w="6350"/>
           </p:spPr>
           <p:style>
             <a:lnRef idx="2">
@@ -23175,7 +23210,7 @@
               <a:avLst/>
             </a:prstGeom>
             <a:noFill/>
-            <a:ln>
+            <a:ln w="6350">
               <a:solidFill>
                 <a:srgbClr val="FF0000"/>
               </a:solidFill>
@@ -23220,7 +23255,7 @@
             <a:prstGeom prst="line">
               <a:avLst/>
             </a:prstGeom>
-            <a:ln w="38100">
+            <a:ln w="6350">
               <a:solidFill>
                 <a:schemeClr val="accent6">
                   <a:lumMod val="60000"/>
@@ -23274,7 +23309,7 @@
               <a:avLst/>
             </a:prstGeom>
             <a:noFill/>
-            <a:ln>
+            <a:ln w="6350">
               <a:solidFill>
                 <a:schemeClr val="accent2"/>
               </a:solidFill>
@@ -23324,7 +23359,7 @@
               <a:avLst/>
             </a:prstGeom>
             <a:noFill/>
-            <a:ln>
+            <a:ln w="6350">
               <a:solidFill>
                 <a:schemeClr val="accent1"/>
               </a:solidFill>
@@ -23377,7 +23412,7 @@
             </a:avLst>
           </a:prstGeom>
           <a:noFill/>
-          <a:ln>
+          <a:ln w="6350">
             <a:solidFill>
               <a:schemeClr val="accent1">
                 <a:lumMod val="75000"/>
@@ -23483,7 +23518,7 @@
             </a:avLst>
           </a:prstGeom>
           <a:noFill/>
-          <a:ln>
+          <a:ln w="6350">
             <a:solidFill>
               <a:schemeClr val="accent1">
                 <a:lumMod val="75000"/>
@@ -23589,7 +23624,7 @@
             </a:avLst>
           </a:prstGeom>
           <a:noFill/>
-          <a:ln w="19050">
+          <a:ln w="6350">
             <a:solidFill>
               <a:srgbClr val="FFFF00"/>
             </a:solidFill>
@@ -23648,7 +23683,7 @@
           <a:prstGeom prst="straightConnector1">
             <a:avLst/>
           </a:prstGeom>
-          <a:ln w="3175">
+          <a:ln w="6350">
             <a:solidFill>
               <a:schemeClr val="accent6">
                 <a:lumMod val="60000"/>
@@ -23691,7 +23726,7 @@
           <a:prstGeom prst="straightConnector1">
             <a:avLst/>
           </a:prstGeom>
-          <a:ln w="3175">
+          <a:ln w="6350">
             <a:solidFill>
               <a:schemeClr val="accent6">
                 <a:lumMod val="60000"/>
@@ -23734,7 +23769,7 @@
           <a:prstGeom prst="straightConnector1">
             <a:avLst/>
           </a:prstGeom>
-          <a:ln w="3175">
+          <a:ln w="6350">
             <a:solidFill>
               <a:schemeClr val="accent6">
                 <a:lumMod val="60000"/>
@@ -23782,7 +23817,7 @@
               <a:lumOff val="80000"/>
             </a:schemeClr>
           </a:solidFill>
-          <a:ln>
+          <a:ln w="6350">
             <a:solidFill>
               <a:schemeClr val="accent5">
                 <a:lumMod val="75000"/>
@@ -23868,7 +23903,7 @@
           <a:prstGeom prst="straightConnector1">
             <a:avLst/>
           </a:prstGeom>
-          <a:ln w="3175">
+          <a:ln w="6350">
             <a:solidFill>
               <a:schemeClr val="accent4">
                 <a:lumMod val="60000"/>
@@ -23911,7 +23946,7 @@
           <a:prstGeom prst="straightConnector1">
             <a:avLst/>
           </a:prstGeom>
-          <a:ln w="3175">
+          <a:ln w="6350">
             <a:solidFill>
               <a:schemeClr val="accent4">
                 <a:lumMod val="60000"/>
@@ -23954,7 +23989,7 @@
           <a:prstGeom prst="straightConnector1">
             <a:avLst/>
           </a:prstGeom>
-          <a:ln w="3175">
+          <a:ln w="6350">
             <a:solidFill>
               <a:schemeClr val="accent4">
                 <a:lumMod val="60000"/>
@@ -23995,6 +24030,7 @@
             <a:avLst/>
           </a:prstGeom>
           <a:noFill/>
+          <a:ln w="6350"/>
         </p:spPr>
         <p:style>
           <a:lnRef idx="2">
@@ -24041,7 +24077,7 @@
               <a:gd name="adj" fmla="val 7576"/>
             </a:avLst>
           </a:prstGeom>
-          <a:ln>
+          <a:ln w="6350">
             <a:solidFill>
               <a:schemeClr val="bg1">
                 <a:lumMod val="85000"/>
@@ -24100,7 +24136,7 @@
               <a:gd name="adj" fmla="val 7576"/>
             </a:avLst>
           </a:prstGeom>
-          <a:ln>
+          <a:ln w="6350">
             <a:solidFill>
               <a:schemeClr val="bg1">
                 <a:lumMod val="85000"/>
@@ -24158,7 +24194,7 @@
             <a:avLst/>
           </a:prstGeom>
           <a:noFill/>
-          <a:ln>
+          <a:ln w="6350">
             <a:solidFill>
               <a:srgbClr val="FF0000"/>
             </a:solidFill>
@@ -24206,7 +24242,7 @@
           <a:prstGeom prst="straightConnector1">
             <a:avLst/>
           </a:prstGeom>
-          <a:ln w="3175">
+          <a:ln w="6350">
             <a:solidFill>
               <a:srgbClr val="00B0F0"/>
             </a:solidFill>
@@ -24247,7 +24283,7 @@
           <a:prstGeom prst="straightConnector1">
             <a:avLst/>
           </a:prstGeom>
-          <a:ln w="3175">
+          <a:ln w="6350">
             <a:solidFill>
               <a:srgbClr val="00B0F0"/>
             </a:solidFill>
@@ -24288,7 +24324,7 @@
           <a:prstGeom prst="straightConnector1">
             <a:avLst/>
           </a:prstGeom>
-          <a:ln w="3175">
+          <a:ln w="6350">
             <a:solidFill>
               <a:srgbClr val="00B0F0"/>
             </a:solidFill>
@@ -24329,7 +24365,7 @@
           <a:prstGeom prst="straightConnector1">
             <a:avLst/>
           </a:prstGeom>
-          <a:ln w="3175">
+          <a:ln w="6350">
             <a:solidFill>
               <a:srgbClr val="00B0F0"/>
             </a:solidFill>
@@ -24370,7 +24406,7 @@
           <a:prstGeom prst="straightConnector1">
             <a:avLst/>
           </a:prstGeom>
-          <a:ln w="3175">
+          <a:ln w="6350">
             <a:solidFill>
               <a:srgbClr val="00B0F0"/>
             </a:solidFill>
@@ -24410,7 +24446,7 @@
               <a:gd name="adj" fmla="val 7576"/>
             </a:avLst>
           </a:prstGeom>
-          <a:ln>
+          <a:ln w="6350">
             <a:solidFill>
               <a:schemeClr val="accent2"/>
             </a:solidFill>
@@ -24467,7 +24503,7 @@
               <a:gd name="adj" fmla="val 7576"/>
             </a:avLst>
           </a:prstGeom>
-          <a:ln>
+          <a:ln w="6350">
             <a:solidFill>
               <a:schemeClr val="accent2"/>
             </a:solidFill>
@@ -24524,7 +24560,7 @@
               <a:gd name="adj" fmla="val 7576"/>
             </a:avLst>
           </a:prstGeom>
-          <a:ln>
+          <a:ln w="6350">
             <a:solidFill>
               <a:schemeClr val="accent2"/>
             </a:solidFill>

</xml_diff>

<commit_message>
docs: update README and architecture diagram
</commit_message>
<xml_diff>
--- a/dc3/doc/framework/iot-dc3-architecture.pptx
+++ b/dc3/doc/framework/iot-dc3-architecture.pptx
@@ -205,7 +205,7 @@
           <a:p>
             <a:fld id="{6EE3B9A8-D85C-445A-8AE4-653E2C11D910}" type="datetimeFigureOut">
               <a:rPr lang="zh-CN" altLang="en-US" smtClean="0"/>
-              <a:t>2020/2/22</a:t>
+              <a:t>2020/3/2</a:t>
             </a:fld>
             <a:endParaRPr lang="zh-CN" altLang="en-US"/>
           </a:p>
@@ -787,7 +787,7 @@
           <a:p>
             <a:fld id="{9BF28833-E291-4948-8DAA-251BCB67763B}" type="datetimeFigureOut">
               <a:rPr lang="zh-CN" altLang="en-US" smtClean="0"/>
-              <a:t>2020/2/22</a:t>
+              <a:t>2020/3/2</a:t>
             </a:fld>
             <a:endParaRPr lang="zh-CN" altLang="en-US"/>
           </a:p>
@@ -985,7 +985,7 @@
           <a:p>
             <a:fld id="{9BF28833-E291-4948-8DAA-251BCB67763B}" type="datetimeFigureOut">
               <a:rPr lang="zh-CN" altLang="en-US" smtClean="0"/>
-              <a:t>2020/2/22</a:t>
+              <a:t>2020/3/2</a:t>
             </a:fld>
             <a:endParaRPr lang="zh-CN" altLang="en-US"/>
           </a:p>
@@ -1193,7 +1193,7 @@
           <a:p>
             <a:fld id="{9BF28833-E291-4948-8DAA-251BCB67763B}" type="datetimeFigureOut">
               <a:rPr lang="zh-CN" altLang="en-US" smtClean="0"/>
-              <a:t>2020/2/22</a:t>
+              <a:t>2020/3/2</a:t>
             </a:fld>
             <a:endParaRPr lang="zh-CN" altLang="en-US"/>
           </a:p>
@@ -1391,7 +1391,7 @@
           <a:p>
             <a:fld id="{9BF28833-E291-4948-8DAA-251BCB67763B}" type="datetimeFigureOut">
               <a:rPr lang="zh-CN" altLang="en-US" smtClean="0"/>
-              <a:t>2020/2/22</a:t>
+              <a:t>2020/3/2</a:t>
             </a:fld>
             <a:endParaRPr lang="zh-CN" altLang="en-US"/>
           </a:p>
@@ -1666,7 +1666,7 @@
           <a:p>
             <a:fld id="{9BF28833-E291-4948-8DAA-251BCB67763B}" type="datetimeFigureOut">
               <a:rPr lang="zh-CN" altLang="en-US" smtClean="0"/>
-              <a:t>2020/2/22</a:t>
+              <a:t>2020/3/2</a:t>
             </a:fld>
             <a:endParaRPr lang="zh-CN" altLang="en-US"/>
           </a:p>
@@ -1931,7 +1931,7 @@
           <a:p>
             <a:fld id="{9BF28833-E291-4948-8DAA-251BCB67763B}" type="datetimeFigureOut">
               <a:rPr lang="zh-CN" altLang="en-US" smtClean="0"/>
-              <a:t>2020/2/22</a:t>
+              <a:t>2020/3/2</a:t>
             </a:fld>
             <a:endParaRPr lang="zh-CN" altLang="en-US"/>
           </a:p>
@@ -2343,7 +2343,7 @@
           <a:p>
             <a:fld id="{9BF28833-E291-4948-8DAA-251BCB67763B}" type="datetimeFigureOut">
               <a:rPr lang="zh-CN" altLang="en-US" smtClean="0"/>
-              <a:t>2020/2/22</a:t>
+              <a:t>2020/3/2</a:t>
             </a:fld>
             <a:endParaRPr lang="zh-CN" altLang="en-US"/>
           </a:p>
@@ -2484,7 +2484,7 @@
           <a:p>
             <a:fld id="{9BF28833-E291-4948-8DAA-251BCB67763B}" type="datetimeFigureOut">
               <a:rPr lang="zh-CN" altLang="en-US" smtClean="0"/>
-              <a:t>2020/2/22</a:t>
+              <a:t>2020/3/2</a:t>
             </a:fld>
             <a:endParaRPr lang="zh-CN" altLang="en-US"/>
           </a:p>
@@ -2597,7 +2597,7 @@
           <a:p>
             <a:fld id="{9BF28833-E291-4948-8DAA-251BCB67763B}" type="datetimeFigureOut">
               <a:rPr lang="zh-CN" altLang="en-US" smtClean="0"/>
-              <a:t>2020/2/22</a:t>
+              <a:t>2020/3/2</a:t>
             </a:fld>
             <a:endParaRPr lang="zh-CN" altLang="en-US"/>
           </a:p>
@@ -2908,7 +2908,7 @@
           <a:p>
             <a:fld id="{9BF28833-E291-4948-8DAA-251BCB67763B}" type="datetimeFigureOut">
               <a:rPr lang="zh-CN" altLang="en-US" smtClean="0"/>
-              <a:t>2020/2/22</a:t>
+              <a:t>2020/3/2</a:t>
             </a:fld>
             <a:endParaRPr lang="zh-CN" altLang="en-US"/>
           </a:p>
@@ -3196,7 +3196,7 @@
           <a:p>
             <a:fld id="{9BF28833-E291-4948-8DAA-251BCB67763B}" type="datetimeFigureOut">
               <a:rPr lang="zh-CN" altLang="en-US" smtClean="0"/>
-              <a:t>2020/2/22</a:t>
+              <a:t>2020/3/2</a:t>
             </a:fld>
             <a:endParaRPr lang="zh-CN" altLang="en-US"/>
           </a:p>
@@ -3437,7 +3437,7 @@
           <a:p>
             <a:fld id="{9BF28833-E291-4948-8DAA-251BCB67763B}" type="datetimeFigureOut">
               <a:rPr lang="zh-CN" altLang="en-US" smtClean="0"/>
-              <a:t>2020/2/22</a:t>
+              <a:t>2020/3/2</a:t>
             </a:fld>
             <a:endParaRPr lang="zh-CN" altLang="en-US"/>
           </a:p>

</xml_diff>